<commit_message>
Update presentation date and methodological notes
</commit_message>
<xml_diff>
--- a/presentation/FraudShield_BI_Module_8_Presentation.pptx
+++ b/presentation/FraudShield_BI_Module_8_Presentation.pptx
@@ -688,7 +688,7 @@
           <a:p>
             <a:r>
               <a:rPr lang="en-US" dirty="0"/>
-              <a:t>In conclusion, this project showed that fraud detection should be evaluated as both a technical and business problem. Accuracy alone is not enough in an imbalanced fraud dataset. Gradient boosting was the stronger model, and threshold selection changed the practical business outcome. The dashboard helps decision-makers see the tradeoff between fraud capture, customer friction, review volume, and cost. For project closure, the GitHub package includes the README, validated outputs, figures, final reports, presentation materials, the editable Power BI dashboard, its PDF export, and a data README explaining how to obtain the Kaggle dataset without uploading large raw files.</a:t>
+              <a:t>In conclusion, this project showed that fraud detection should be evaluated as both a technical and business problem. Accuracy alone is not enough in an imbalanced fraud dataset. Gradient boosting was the stronger model, and threshold selection changed the practical business outcome. The dashboard helps decision-makers see the tradeoff between fraud capture, customer friction, review volume, and cost. I also added methodological notes for responsible interpretation. In a production setting, threshold selection should use a validation sample and final results should be confirmed on an untouched holdout dataset. Future work should also test false-positive costs that vary by transaction value, repeat segmentation using the selected gradient boosting threshold, and evaluate fairness with and without sensitive attributes such as gender. For project closure, the GitHub package includes the README, validated outputs, figures, final reports, presentation materials, the editable Power BI dashboard, its PDF export, dashboard page previews, and a data README explaining how to obtain the Kaggle dataset without uploading large raw files.</a:t>
             </a:r>
             <a:endParaRPr lang="en-US" dirty="0"/>
           </a:p>
@@ -952,7 +952,7 @@
           <a:p>
             <a:r>
               <a:rPr lang="en-US" dirty="0"/>
-              <a:t>The dataset came from the Kaggle credit card transactions fraud detection dataset, which was generated using Sparkov and contains simulated transaction records. I used the training file with 1,296,675 records and the testing file with 555,719 records. The fraud rate in the training data was only about 0.579 percent, which confirmed that this was a highly imbalanced classification problem. Ethically, I did not use employer data, real customer data, or internal fraud procedures. I also excluded direct identifiers such as credit card number, names, transaction number, street address, and merchant name.</a:t>
+              <a:t>The dataset came from the Kaggle credit card transactions fraud detection dataset, which was generated using Sparkov and contains simulated transaction records. I used the training file with 1,296,675 records and the testing file with 555,719 records. The fraud rate in the training data was only about 0.579 percent, which confirmed that this was a highly imbalanced classification problem. The supplied train/test files were practical for the capstone, but a production version should also use a validation sample and an untouched holdout sample for threshold selection and final confirmation. Ethically, I did not use employer data, real customer data, or internal fraud procedures. I also excluded direct identifiers such as credit card number, names, transaction number, street address, and merchant name.</a:t>
             </a:r>
             <a:endParaRPr lang="en-US" dirty="0"/>
           </a:p>
@@ -2096,55 +2096,34 @@
           <a:bodyPr wrap="square" lIns="254" tIns="254" rIns="254" bIns="254" rtlCol="0" anchor="ctr"/>
           <a:lstStyle/>
           <a:p>
-            <a:pPr indent="0" marL="0">
-              <a:buNone/>
-            </a:pPr>
-            <a:r>
-              <a:rPr lang="en-US" sz="1280" dirty="0">
-                <a:solidFill>
-                  <a:srgbClr val="DDEAF6"/>
-                </a:solidFill>
-                <a:latin typeface="Aptos" pitchFamily="34" charset="0"/>
-                <a:ea typeface="Aptos" pitchFamily="34" charset="-122"/>
-                <a:cs typeface="Aptos" pitchFamily="34" charset="-120"/>
+            <a:r>
+              <a:rPr sz="1800">
+                <a:solidFill>
+                  <a:srgbClr val="D7E6F5"/>
+                </a:solidFill>
               </a:rPr>
               <a:t>Atta Febri-Yeboah</a:t>
             </a:r>
-            <a:endParaRPr lang="en-US" sz="1280" dirty="0"/>
-          </a:p>
-          <a:p>
-            <a:pPr indent="0" marL="0">
-              <a:buNone/>
-            </a:pPr>
-            <a:r>
-              <a:rPr lang="en-US" sz="1280" dirty="0">
-                <a:solidFill>
-                  <a:srgbClr val="DDEAF6"/>
-                </a:solidFill>
-                <a:latin typeface="Aptos" pitchFamily="34" charset="0"/>
-                <a:ea typeface="Aptos" pitchFamily="34" charset="-122"/>
-                <a:cs typeface="Aptos" pitchFamily="34" charset="-120"/>
+          </a:p>
+          <a:p>
+            <a:r>
+              <a:rPr sz="1800">
+                <a:solidFill>
+                  <a:srgbClr val="D7E6F5"/>
+                </a:solidFill>
               </a:rPr>
               <a:t>Colorado State University Global</a:t>
             </a:r>
-            <a:endParaRPr lang="en-US" sz="1280" dirty="0"/>
-          </a:p>
-          <a:p>
-            <a:pPr indent="0" marL="0">
-              <a:buNone/>
-            </a:pPr>
-            <a:r>
-              <a:rPr lang="en-US" sz="1280" dirty="0">
-                <a:solidFill>
-                  <a:srgbClr val="DDEAF6"/>
-                </a:solidFill>
-                <a:latin typeface="Aptos" pitchFamily="34" charset="0"/>
-                <a:ea typeface="Aptos" pitchFamily="34" charset="-122"/>
-                <a:cs typeface="Aptos" pitchFamily="34" charset="-120"/>
-              </a:rPr>
-              <a:t>Dr. Jamia Mills | June 2026</a:t>
-            </a:r>
-            <a:endParaRPr lang="en-US" sz="1280" dirty="0"/>
+          </a:p>
+          <a:p>
+            <a:r>
+              <a:rPr sz="1800">
+                <a:solidFill>
+                  <a:srgbClr val="D7E6F5"/>
+                </a:solidFill>
+              </a:rPr>
+              <a:t>Dr. Jamia Mills | July 2026</a:t>
+            </a:r>
           </a:p>
         </p:txBody>
       </p:sp>
@@ -2176,6 +2155,10 @@
             <a:prstDash val="solid"/>
           </a:ln>
         </p:spPr>
+        <p:txBody>
+          <a:bodyPr/>
+          <a:p/>
+        </p:txBody>
       </p:sp>
       <p:pic>
         <p:nvPicPr>
@@ -2227,6 +2210,10 @@
             <a:prstDash val="solid"/>
           </a:ln>
         </p:spPr>
+        <p:txBody>
+          <a:bodyPr/>
+          <a:p/>
+        </p:txBody>
       </p:sp>
       <p:sp>
         <p:nvSpPr>
@@ -2334,6 +2321,10 @@
             <a:prstDash val="solid"/>
           </a:ln>
         </p:spPr>
+        <p:txBody>
+          <a:bodyPr/>
+          <a:p/>
+        </p:txBody>
       </p:sp>
       <p:sp>
         <p:nvSpPr>
@@ -3631,21 +3622,9 @@
           <a:bodyPr wrap="square" lIns="0" tIns="0" rIns="0" bIns="0" rtlCol="0" anchor="ctr"/>
           <a:lstStyle/>
           <a:p>
-            <a:pPr indent="0" marL="0">
-              <a:buNone/>
-            </a:pPr>
-            <a:r>
-              <a:rPr lang="en-US" sz="850" b="1" dirty="0">
-                <a:solidFill>
-                  <a:srgbClr val="2A9D8F"/>
-                </a:solidFill>
-                <a:latin typeface="Aptos" pitchFamily="34" charset="0"/>
-                <a:ea typeface="Aptos" pitchFamily="34" charset="-122"/>
-                <a:cs typeface="Aptos" pitchFamily="34" charset="-120"/>
-              </a:rPr>
-              <a:t>FINAL DELIVERABLES</a:t>
-            </a:r>
-            <a:endParaRPr lang="en-US" sz="850" dirty="0"/>
+            <a:r>
+              <a:t>FINAL DELIVERABLES &amp; NEXT STEPS</a:t>
+            </a:r>
           </a:p>
         </p:txBody>
       </p:sp>
@@ -3672,21 +3651,9 @@
           </a:bodyPr>
           <a:lstStyle/>
           <a:p>
-            <a:pPr indent="0" marL="0">
-              <a:buNone/>
-            </a:pPr>
-            <a:r>
-              <a:rPr lang="en-US" sz="2700" b="1" dirty="0">
-                <a:solidFill>
-                  <a:srgbClr val="0B1F3A"/>
-                </a:solidFill>
-                <a:latin typeface="Aptos Display" pitchFamily="34" charset="0"/>
-                <a:ea typeface="Aptos Display" pitchFamily="34" charset="-122"/>
-                <a:cs typeface="Aptos Display" pitchFamily="34" charset="-120"/>
-              </a:rPr>
-              <a:t>Conclusion and Project Closure</a:t>
-            </a:r>
-            <a:endParaRPr lang="en-US" sz="2700" dirty="0"/>
+            <a:r>
+              <a:t>Conclusion, Validation Notes, and Project Closure</a:t>
+            </a:r>
           </a:p>
         </p:txBody>
       </p:sp>
@@ -3712,6 +3679,10 @@
             <a:prstDash val="solid"/>
           </a:ln>
         </p:spPr>
+        <p:txBody>
+          <a:bodyPr/>
+          <a:p/>
+        </p:txBody>
       </p:sp>
       <p:sp>
         <p:nvSpPr>
@@ -3775,74 +3746,104 @@
           </a:bodyPr>
           <a:lstStyle/>
           <a:p>
-            <a:r>
-              <a:rPr lang="en-US" sz="1450" dirty="0">
-                <a:solidFill>
-                  <a:srgbClr val="1E293B"/>
-                </a:solidFill>
-                <a:latin typeface="Aptos" pitchFamily="34" charset="0"/>
-                <a:ea typeface="Aptos" pitchFamily="34" charset="-122"/>
-                <a:cs typeface="Aptos" pitchFamily="34" charset="-120"/>
-              </a:rPr>
+            <a:pPr>
+              <a:defRPr sz="1350">
+                <a:solidFill>
+                  <a:srgbClr val="1C2D3B"/>
+                </a:solidFill>
+              </a:defRPr>
+            </a:pPr>
+            <a:r>
               <a:t>Class imbalance makes accuracy alone misleading.</a:t>
             </a:r>
             <a:endParaRPr lang="en-US" sz="1450" dirty="0"/>
           </a:p>
           <a:p>
-            <a:r>
-              <a:rPr lang="en-US" sz="1450" dirty="0">
-                <a:solidFill>
-                  <a:srgbClr val="1E293B"/>
-                </a:solidFill>
-                <a:latin typeface="Aptos" pitchFamily="34" charset="0"/>
-                <a:ea typeface="Aptos" pitchFamily="34" charset="-122"/>
-                <a:cs typeface="Aptos" pitchFamily="34" charset="-120"/>
-              </a:rPr>
-              <a:t>Gradient boosting outperformed logistic regression for this simulated dataset.</a:t>
-            </a:r>
-            <a:endParaRPr lang="en-US" sz="1450" dirty="0"/>
-          </a:p>
-          <a:p>
-            <a:r>
-              <a:rPr lang="en-US" sz="1450" dirty="0">
-                <a:solidFill>
-                  <a:srgbClr val="1E293B"/>
-                </a:solidFill>
-                <a:latin typeface="Aptos" pitchFamily="34" charset="0"/>
-                <a:ea typeface="Aptos" pitchFamily="34" charset="-122"/>
-                <a:cs typeface="Aptos" pitchFamily="34" charset="-120"/>
-              </a:rPr>
-              <a:t>Threshold selection changed fraud capture, false positives, workload, and cost.</a:t>
-            </a:r>
-            <a:endParaRPr lang="en-US" sz="1450" dirty="0"/>
-          </a:p>
-          <a:p>
-            <a:r>
-              <a:rPr lang="en-US" sz="1450" dirty="0">
-                <a:solidFill>
-                  <a:srgbClr val="1E293B"/>
-                </a:solidFill>
-                <a:latin typeface="Aptos" pitchFamily="34" charset="0"/>
-                <a:ea typeface="Aptos" pitchFamily="34" charset="-122"/>
-                <a:cs typeface="Aptos" pitchFamily="34" charset="-120"/>
-              </a:rPr>
-              <a:t>False-positive monitoring should be segmented, especially for travel and high-dollar transactions.</a:t>
-            </a:r>
-            <a:endParaRPr lang="en-US" sz="1450" dirty="0"/>
-          </a:p>
-          <a:p>
-            <a:r>
-              <a:rPr lang="en-US" sz="1450" dirty="0">
-                <a:solidFill>
-                  <a:srgbClr val="1E293B"/>
-                </a:solidFill>
-                <a:latin typeface="Aptos" pitchFamily="34" charset="0"/>
-                <a:ea typeface="Aptos" pitchFamily="34" charset="-122"/>
-                <a:cs typeface="Aptos" pitchFamily="34" charset="-120"/>
-              </a:rPr>
-              <a:t>Power BI can make fraud tradeoffs clear for business decision-makers.</a:t>
-            </a:r>
-            <a:endParaRPr lang="en-US" sz="1450" dirty="0"/>
+            <a:pPr>
+              <a:defRPr sz="1350">
+                <a:solidFill>
+                  <a:srgbClr val="1C2D3B"/>
+                </a:solidFill>
+              </a:defRPr>
+            </a:pPr>
+            <a:r>
+              <a:t>Gradient boosting outperformed logistic regression.</a:t>
+            </a:r>
+          </a:p>
+          <a:p>
+            <a:pPr>
+              <a:defRPr sz="1350">
+                <a:solidFill>
+                  <a:srgbClr val="1C2D3B"/>
+                </a:solidFill>
+              </a:defRPr>
+            </a:pPr>
+            <a:r>
+              <a:t>Threshold selection changed fraud capture, workload, and cost.</a:t>
+            </a:r>
+          </a:p>
+          <a:p>
+            <a:pPr>
+              <a:defRPr sz="1350">
+                <a:solidFill>
+                  <a:srgbClr val="1C2D3B"/>
+                </a:solidFill>
+              </a:defRPr>
+            </a:pPr>
+            <a:r>
+              <a:t>Power BI made fraud tradeoffs clear for business stakeholders.</a:t>
+            </a:r>
+          </a:p>
+          <a:p>
+            <a:pPr>
+              <a:spcBef>
+                <a:spcPts val="800"/>
+              </a:spcBef>
+              <a:defRPr b="1" sz="1400">
+                <a:solidFill>
+                  <a:srgbClr val="0B2C48"/>
+                </a:solidFill>
+              </a:defRPr>
+            </a:pPr>
+            <a:r>
+              <a:t>Future validation notes</a:t>
+            </a:r>
+          </a:p>
+          <a:p>
+            <a:pPr>
+              <a:defRPr sz="1350">
+                <a:solidFill>
+                  <a:srgbClr val="1C2D3B"/>
+                </a:solidFill>
+              </a:defRPr>
+            </a:pPr>
+            <a:r>
+              <a:t>Use validation and untouched holdout samples for threshold selection.</a:t>
+            </a:r>
+          </a:p>
+          <a:p>
+            <a:pPr>
+              <a:defRPr sz="1350">
+                <a:solidFill>
+                  <a:srgbClr val="1C2D3B"/>
+                </a:solidFill>
+              </a:defRPr>
+            </a:pPr>
+            <a:r>
+              <a:t>Expand false-positive costs beyond a fixed per-alert amount.</a:t>
+            </a:r>
+          </a:p>
+          <a:p>
+            <a:pPr>
+              <a:defRPr sz="1350">
+                <a:solidFill>
+                  <a:srgbClr val="1C2D3B"/>
+                </a:solidFill>
+              </a:defRPr>
+            </a:pPr>
+            <a:r>
+              <a:t>Recheck segmentation and fairness using the selected model.</a:t>
+            </a:r>
           </a:p>
         </p:txBody>
       </p:sp>
@@ -3911,6 +3912,10 @@
             <a:prstDash val="solid"/>
           </a:ln>
         </p:spPr>
+        <p:txBody>
+          <a:bodyPr/>
+          <a:p/>
+        </p:txBody>
       </p:sp>
       <p:sp>
         <p:nvSpPr>
@@ -4018,6 +4023,10 @@
             <a:prstDash val="solid"/>
           </a:ln>
         </p:spPr>
+        <p:txBody>
+          <a:bodyPr/>
+          <a:p/>
+        </p:txBody>
       </p:sp>
       <p:sp>
         <p:nvSpPr>
@@ -4125,6 +4134,10 @@
             <a:prstDash val="solid"/>
           </a:ln>
         </p:spPr>
+        <p:txBody>
+          <a:bodyPr/>
+          <a:p/>
+        </p:txBody>
       </p:sp>
       <p:sp>
         <p:nvSpPr>
@@ -4232,6 +4245,10 @@
             <a:prstDash val="solid"/>
           </a:ln>
         </p:spPr>
+        <p:txBody>
+          <a:bodyPr/>
+          <a:p/>
+        </p:txBody>
       </p:sp>
       <p:sp>
         <p:nvSpPr>
@@ -4339,6 +4356,10 @@
             <a:prstDash val="solid"/>
           </a:ln>
         </p:spPr>
+        <p:txBody>
+          <a:bodyPr/>
+          <a:p/>
+        </p:txBody>
       </p:sp>
       <p:sp>
         <p:nvSpPr>
@@ -4446,6 +4467,10 @@
             <a:prstDash val="solid"/>
           </a:ln>
         </p:spPr>
+        <p:txBody>
+          <a:bodyPr/>
+          <a:p/>
+        </p:txBody>
       </p:sp>
       <p:sp>
         <p:nvSpPr>
@@ -4553,6 +4578,10 @@
             <a:prstDash val="solid"/>
           </a:ln>
         </p:spPr>
+        <p:txBody>
+          <a:bodyPr/>
+          <a:p/>
+        </p:txBody>
       </p:sp>
       <p:sp>
         <p:nvSpPr>
@@ -4577,21 +4606,14 @@
           </a:bodyPr>
           <a:lstStyle/>
           <a:p>
-            <a:pPr algn="ctr" indent="0" marL="0">
-              <a:buNone/>
-            </a:pPr>
-            <a:r>
-              <a:rPr lang="en-US" sz="1380" b="1" dirty="0">
+            <a:r>
+              <a:rPr sz="1400">
                 <a:solidFill>
                   <a:srgbClr val="FFFFFF"/>
                 </a:solidFill>
-                <a:latin typeface="Aptos Display" pitchFamily="34" charset="0"/>
-                <a:ea typeface="Aptos Display" pitchFamily="34" charset="-122"/>
-                <a:cs typeface="Aptos Display" pitchFamily="34" charset="-120"/>
-              </a:rPr>
-              <a:t>Final recommendation: use model and threshold governance that balances fraud loss, customer friction, and operational capacity.</a:t>
-            </a:r>
-            <a:endParaRPr lang="en-US" sz="1380" dirty="0"/>
+              </a:rPr>
+              <a:t>Final recommendation: govern model and threshold choices with fraud loss, customer friction, operational capacity, and fairness in view.</a:t>
+            </a:r>
           </a:p>
         </p:txBody>
       </p:sp>
@@ -6007,6 +6029,10 @@
             <a:prstDash val="solid"/>
           </a:ln>
         </p:spPr>
+        <p:txBody>
+          <a:bodyPr/>
+          <a:p/>
+        </p:txBody>
       </p:sp>
       <p:pic>
         <p:nvPicPr>
@@ -6058,6 +6084,10 @@
             <a:prstDash val="solid"/>
           </a:ln>
         </p:spPr>
+        <p:txBody>
+          <a:bodyPr/>
+          <a:p/>
+        </p:txBody>
       </p:sp>
       <p:sp>
         <p:nvSpPr>
@@ -6165,6 +6195,10 @@
             <a:prstDash val="solid"/>
           </a:ln>
         </p:spPr>
+        <p:txBody>
+          <a:bodyPr/>
+          <a:p/>
+        </p:txBody>
       </p:sp>
       <p:sp>
         <p:nvSpPr>
@@ -6272,6 +6306,10 @@
             <a:prstDash val="solid"/>
           </a:ln>
         </p:spPr>
+        <p:txBody>
+          <a:bodyPr/>
+          <a:p/>
+        </p:txBody>
       </p:sp>
       <p:sp>
         <p:nvSpPr>
@@ -6416,45 +6454,21 @@
           <a:lstStyle/>
           <a:p>
             <a:r>
-              <a:rPr lang="en-US" sz="1350" dirty="0">
-                <a:solidFill>
-                  <a:srgbClr val="1E293B"/>
-                </a:solidFill>
-                <a:latin typeface="Aptos" pitchFamily="34" charset="0"/>
-                <a:ea typeface="Aptos" pitchFamily="34" charset="-122"/>
-                <a:cs typeface="Aptos" pitchFamily="34" charset="-120"/>
-              </a:rPr>
+              <a:rPr sz="1500"/>
               <a:t>Quantitative secondary analysis using a simulated Kaggle/Sparkov transaction dataset.</a:t>
             </a:r>
-            <a:endParaRPr lang="en-US" sz="1350" dirty="0"/>
-          </a:p>
-          <a:p>
-            <a:r>
-              <a:rPr lang="en-US" sz="1350" dirty="0">
-                <a:solidFill>
-                  <a:srgbClr val="1E293B"/>
-                </a:solidFill>
-                <a:latin typeface="Aptos" pitchFamily="34" charset="0"/>
-                <a:ea typeface="Aptos" pitchFamily="34" charset="-122"/>
-                <a:cs typeface="Aptos" pitchFamily="34" charset="-120"/>
-              </a:rPr>
-              <a:t>Train/test split already supplied, reducing leakage from evaluation data.</a:t>
-            </a:r>
-            <a:endParaRPr lang="en-US" sz="1350" dirty="0"/>
-          </a:p>
-          <a:p>
-            <a:r>
-              <a:rPr lang="en-US" sz="1350" dirty="0">
-                <a:solidFill>
-                  <a:srgbClr val="1E293B"/>
-                </a:solidFill>
-                <a:latin typeface="Aptos" pitchFamily="34" charset="0"/>
-                <a:ea typeface="Aptos" pitchFamily="34" charset="-122"/>
-                <a:cs typeface="Aptos" pitchFamily="34" charset="-120"/>
-              </a:rPr>
+          </a:p>
+          <a:p>
+            <a:r>
+              <a:rPr sz="1500"/>
+              <a:t>Pre-split train/test files used; production work should add validation and holdout samples.</a:t>
+            </a:r>
+          </a:p>
+          <a:p>
+            <a:r>
+              <a:rPr sz="1500"/>
               <a:t>Predictors included amount, hour, age, city population, distance, category, and gender.</a:t>
             </a:r>
-            <a:endParaRPr lang="en-US" sz="1350" dirty="0"/>
           </a:p>
         </p:txBody>
       </p:sp>

</xml_diff>

<commit_message>
Fix presentation folder structure wording
</commit_message>
<xml_diff>
--- a/presentation/FraudShield_BI_Module_8_Presentation.pptx
+++ b/presentation/FraudShield_BI_Module_8_Presentation.pptx
@@ -4164,7 +4164,7 @@
               <a:buNone/>
             </a:pPr>
             <a:r>
-              <a:rPr lang="en-US" sz="1080" b="1" dirty="0">
+              <a:rPr lang="en-US" sz="1050" b="1" dirty="0">
                 <a:solidFill>
                   <a:srgbClr val="2A9D8F"/>
                 </a:solidFill>
@@ -4172,7 +4172,7 @@
                 <a:ea typeface="Aptos" pitchFamily="34" charset="-122"/>
                 <a:cs typeface="Aptos" pitchFamily="34" charset="-120"/>
               </a:rPr>
-              <a:t>figures/</a:t>
+              <a:t>outputs/charts/</a:t>
             </a:r>
             <a:endParaRPr lang="en-US" sz="1080" dirty="0"/>
           </a:p>
@@ -4213,7 +4213,7 @@
                 <a:ea typeface="Aptos" pitchFamily="34" charset="-122"/>
                 <a:cs typeface="Aptos" pitchFamily="34" charset="-120"/>
               </a:rPr>
-              <a:t>charts used in findings and presentation</a:t>
+              <a:t>figures used in findings and presentation</a:t>
             </a:r>
             <a:endParaRPr lang="en-US" sz="1050" dirty="0"/>
           </a:p>
@@ -4275,7 +4275,7 @@
               <a:buNone/>
             </a:pPr>
             <a:r>
-              <a:rPr lang="en-US" sz="1080" b="1" dirty="0">
+              <a:rPr lang="en-US" sz="1050" b="1" dirty="0">
                 <a:solidFill>
                   <a:srgbClr val="2A9D8F"/>
                 </a:solidFill>
@@ -4283,7 +4283,7 @@
                 <a:ea typeface="Aptos" pitchFamily="34" charset="-122"/>
                 <a:cs typeface="Aptos" pitchFamily="34" charset="-120"/>
               </a:rPr>
-              <a:t>reports/</a:t>
+              <a:t>reports + presentation/</a:t>
             </a:r>
             <a:endParaRPr lang="en-US" sz="1080" dirty="0"/>
           </a:p>
@@ -4324,7 +4324,7 @@
                 <a:ea typeface="Aptos" pitchFamily="34" charset="-122"/>
                 <a:cs typeface="Aptos" pitchFamily="34" charset="-120"/>
               </a:rPr>
-              <a:t>final paper and presentation artifacts</a:t>
+              <a:t>final paper, slides, PDF, and speaker script</a:t>
             </a:r>
             <a:endParaRPr lang="en-US" sz="1050" dirty="0"/>
           </a:p>

</xml_diff>